<commit_message>
Update PowerPoint for song #167 in FUBC - Українські
</commit_message>
<xml_diff>
--- a/fubc-ua/167-Без Бога я блукав (Пісні Спасенних №165).pptx
+++ b/fubc-ua/167-Без Бога я блукав (Пісні Спасенних №165).pptx
@@ -689,7 +689,7 @@
           <a:p>
             <a:r>
               <a:rPr lang="en-US" dirty="0"/>
-              <a:t>P · 1/1 · rows:2,1,2,1</a:t>
+              <a:t>P · 1/1 · rows:1,1,2,1</a:t>
             </a:r>
             <a:endParaRPr lang="en-US" dirty="0"/>
           </a:p>
@@ -953,7 +953,7 @@
           <a:p>
             <a:r>
               <a:rPr lang="en-US" dirty="0"/>
-              <a:t>P · 1/1 · rows:2,1,2,1</a:t>
+              <a:t>P · 1/1 · rows:1,1,2,1</a:t>
             </a:r>
             <a:endParaRPr lang="en-US" dirty="0"/>
           </a:p>
@@ -1129,7 +1129,7 @@
           <a:p>
             <a:r>
               <a:rPr lang="en-US" dirty="0"/>
-              <a:t>P · 1/1 · rows:2,1,2,1</a:t>
+              <a:t>P · 1/1 · rows:1,1,2,1</a:t>
             </a:r>
             <a:endParaRPr lang="en-US" dirty="0"/>
           </a:p>
@@ -1305,7 +1305,7 @@
           <a:p>
             <a:r>
               <a:rPr lang="en-US" dirty="0"/>
-              <a:t>P · 1/1 · rows:2,1,2,1</a:t>
+              <a:t>P · 1/1 · rows:1,1,2,1</a:t>
             </a:r>
             <a:endParaRPr lang="en-US" dirty="0"/>
           </a:p>
@@ -1481,7 +1481,7 @@
           <a:p>
             <a:r>
               <a:rPr lang="en-US" dirty="0"/>
-              <a:t>P · 1/1 · rows:2,1,2,1</a:t>
+              <a:t>P · 1/1 · rows:1,1,2,1</a:t>
             </a:r>
             <a:endParaRPr lang="en-US" dirty="0"/>
           </a:p>
@@ -1891,23 +1891,6 @@
             </a:r>
             <a:endParaRPr lang="en-US" sz="5200" dirty="0"/>
           </a:p>
-          <a:p>
-            <a:pPr algn="ctr" indent="0" marL="0">
-              <a:buNone/>
-            </a:pPr>
-            <a:r>
-              <a:rPr lang="en-US" sz="5200" b="1" dirty="0">
-                <a:solidFill>
-                  <a:srgbClr val="FFFFFF"/>
-                </a:solidFill>
-                <a:latin typeface="Arial" pitchFamily="34" charset="0"/>
-                <a:ea typeface="Arial" pitchFamily="34" charset="-122"/>
-                <a:cs typeface="Arial" pitchFamily="34" charset="-120"/>
-              </a:rPr>
-              <a:t>(Пісні Спасенних №165)</a:t>
-            </a:r>
-            <a:endParaRPr lang="en-US" sz="5200" dirty="0"/>
-          </a:p>
         </p:txBody>
       </p:sp>
     </p:spTree>
@@ -2097,24 +2080,7 @@
                 <a:ea typeface="Arial" pitchFamily="34" charset="-122"/>
                 <a:cs typeface="Arial" pitchFamily="34" charset="-120"/>
               </a:rPr>
-              <a:t>Дивний спокій Христос</a:t>
-            </a:r>
-            <a:endParaRPr lang="en-US" sz="5200" dirty="0"/>
-          </a:p>
-          <a:p>
-            <a:pPr algn="ctr" indent="0" marL="0">
-              <a:buNone/>
-            </a:pPr>
-            <a:r>
-              <a:rPr lang="en-US" sz="5200" b="1" i="1" dirty="0">
-                <a:solidFill>
-                  <a:srgbClr val="FFFFFF"/>
-                </a:solidFill>
-                <a:latin typeface="Arial" pitchFamily="34" charset="0"/>
-                <a:ea typeface="Arial" pitchFamily="34" charset="-122"/>
-                <a:cs typeface="Arial" pitchFamily="34" charset="-120"/>
-              </a:rPr>
-              <a:t>дарував (дарував),</a:t>
+              <a:t>Дивний спокій Христос дарував,</a:t>
             </a:r>
             <a:endParaRPr lang="en-US" sz="5200" dirty="0"/>
           </a:p>
@@ -2446,24 +2412,7 @@
                 <a:ea typeface="Arial" pitchFamily="34" charset="-122"/>
                 <a:cs typeface="Arial" pitchFamily="34" charset="-120"/>
               </a:rPr>
-              <a:t>Дивний спокій Христос</a:t>
-            </a:r>
-            <a:endParaRPr lang="en-US" sz="5200" dirty="0"/>
-          </a:p>
-          <a:p>
-            <a:pPr algn="ctr" indent="0" marL="0">
-              <a:buNone/>
-            </a:pPr>
-            <a:r>
-              <a:rPr lang="en-US" sz="5200" b="1" i="1" dirty="0">
-                <a:solidFill>
-                  <a:srgbClr val="FFFFFF"/>
-                </a:solidFill>
-                <a:latin typeface="Arial" pitchFamily="34" charset="0"/>
-                <a:ea typeface="Arial" pitchFamily="34" charset="-122"/>
-                <a:cs typeface="Arial" pitchFamily="34" charset="-120"/>
-              </a:rPr>
-              <a:t>дарував (дарував),</a:t>
+              <a:t>Дивний спокій Христос дарував,</a:t>
             </a:r>
             <a:endParaRPr lang="en-US" sz="5200" dirty="0"/>
           </a:p>
@@ -2724,24 +2673,7 @@
                 <a:ea typeface="Arial" pitchFamily="34" charset="-122"/>
                 <a:cs typeface="Arial" pitchFamily="34" charset="-120"/>
               </a:rPr>
-              <a:t>Дивний спокій Христос</a:t>
-            </a:r>
-            <a:endParaRPr lang="en-US" sz="5200" dirty="0"/>
-          </a:p>
-          <a:p>
-            <a:pPr algn="ctr" indent="0" marL="0">
-              <a:buNone/>
-            </a:pPr>
-            <a:r>
-              <a:rPr lang="en-US" sz="5200" b="1" i="1" dirty="0">
-                <a:solidFill>
-                  <a:srgbClr val="FFFFFF"/>
-                </a:solidFill>
-                <a:latin typeface="Arial" pitchFamily="34" charset="0"/>
-                <a:ea typeface="Arial" pitchFamily="34" charset="-122"/>
-                <a:cs typeface="Arial" pitchFamily="34" charset="-120"/>
-              </a:rPr>
-              <a:t>дарував (дарував),</a:t>
+              <a:t>Дивний спокій Христос дарував,</a:t>
             </a:r>
             <a:endParaRPr lang="en-US" sz="5200" dirty="0"/>
           </a:p>
@@ -3002,24 +2934,7 @@
                 <a:ea typeface="Arial" pitchFamily="34" charset="-122"/>
                 <a:cs typeface="Arial" pitchFamily="34" charset="-120"/>
               </a:rPr>
-              <a:t>Дивний спокій Христос</a:t>
-            </a:r>
-            <a:endParaRPr lang="en-US" sz="5200" dirty="0"/>
-          </a:p>
-          <a:p>
-            <a:pPr algn="ctr" indent="0" marL="0">
-              <a:buNone/>
-            </a:pPr>
-            <a:r>
-              <a:rPr lang="en-US" sz="5200" b="1" i="1" dirty="0">
-                <a:solidFill>
-                  <a:srgbClr val="FFFFFF"/>
-                </a:solidFill>
-                <a:latin typeface="Arial" pitchFamily="34" charset="0"/>
-                <a:ea typeface="Arial" pitchFamily="34" charset="-122"/>
-                <a:cs typeface="Arial" pitchFamily="34" charset="-120"/>
-              </a:rPr>
-              <a:t>дарував (дарував),</a:t>
+              <a:t>Дивний спокій Христос дарував,</a:t>
             </a:r>
             <a:endParaRPr lang="en-US" sz="5200" dirty="0"/>
           </a:p>
@@ -3297,24 +3212,7 @@
                 <a:ea typeface="Arial" pitchFamily="34" charset="-122"/>
                 <a:cs typeface="Arial" pitchFamily="34" charset="-120"/>
               </a:rPr>
-              <a:t>Дивний спокій Христос</a:t>
-            </a:r>
-            <a:endParaRPr lang="en-US" sz="5200" dirty="0"/>
-          </a:p>
-          <a:p>
-            <a:pPr algn="ctr" indent="0" marL="0">
-              <a:buNone/>
-            </a:pPr>
-            <a:r>
-              <a:rPr lang="en-US" sz="5200" b="1" i="1" dirty="0">
-                <a:solidFill>
-                  <a:srgbClr val="FFFFFF"/>
-                </a:solidFill>
-                <a:latin typeface="Arial" pitchFamily="34" charset="0"/>
-                <a:ea typeface="Arial" pitchFamily="34" charset="-122"/>
-                <a:cs typeface="Arial" pitchFamily="34" charset="-120"/>
-              </a:rPr>
-              <a:t>дарував (дарував),</a:t>
+              <a:t>Дивний спокій Христос дарував,</a:t>
             </a:r>
             <a:endParaRPr lang="en-US" sz="5200" dirty="0"/>
           </a:p>

</xml_diff>